<commit_message>
docs: regenera la presentacion con los diagramas corregidos y la autoria Grupo VOX
</commit_message>
<xml_diff>
--- a/Presentacion/TrainerOS_TFI_Fase1-2.pptx
+++ b/Presentacion/TrainerOS_TFI_Fase1-2.pptx
@@ -3358,7 +3358,7 @@
                 </a:solidFill>
                 <a:latin typeface="Segoe UI"/>
               </a:rPr>
-              <a:t>TFI · Desarrollo de Aplicaciones Web · Equipo MMP-SOFTWARE</a:t>
+              <a:t>TFI · Desarrollo de Aplicaciones Web · Grupo VOX</a:t>
             </a:r>
           </a:p>
           <a:p>
@@ -6539,8 +6539,8 @@
         </p:blipFill>
         <p:spPr>
           <a:xfrm>
-            <a:off x="228600" y="467695"/>
-            <a:ext cx="11731752" cy="5776305"/>
+            <a:off x="228600" y="568337"/>
+            <a:ext cx="11731752" cy="5575021"/>
           </a:xfrm>
           <a:prstGeom prst="rect">
             <a:avLst/>

</xml_diff>